<commit_message>
Scrub all placeholder metadata and slide paths
</commit_message>
<xml_diff>
--- a/video/Expired_by_Climate_Slides.pptx
+++ b/video/Expired_by_Climate_Slides.pptx
@@ -4310,7 +4310,7 @@
       </p:sp>
       <p:pic>
         <p:nvPicPr>
-          <p:cNvPr id="3" name="conceptual model" descr="/home/claude/deck/img/model.png"/>
+          <p:cNvPr id="3" name="conceptual model" descr="figures/fig1_model.png"/>
           <p:cNvPicPr>
             <a:picLocks noChangeAspect="1"/>
           </p:cNvPicPr>
@@ -5193,7 +5193,7 @@
       </p:sp>
       <p:pic>
         <p:nvPicPr>
-          <p:cNvPr id="3" name="margin chart" descr="/home/claude/deck/img/margins.png"/>
+          <p:cNvPr id="3" name="margin chart" descr="figures/fig2_margins.png"/>
           <p:cNvPicPr>
             <a:picLocks noChangeAspect="1"/>
           </p:cNvPicPr>
@@ -6076,7 +6076,7 @@
       </p:sp>
       <p:pic>
         <p:nvPicPr>
-          <p:cNvPr id="3" name="humidity chart" descr="/home/claude/deck/img/humidity.png"/>
+          <p:cNvPr id="3" name="humidity chart" descr="figures/fig3_humidity.png"/>
           <p:cNvPicPr>
             <a:picLocks noChangeAspect="1"/>
           </p:cNvPicPr>
@@ -6310,7 +6310,7 @@
       </p:sp>
       <p:pic>
         <p:nvPicPr>
-          <p:cNvPr id="3" name="shelf-life chart" descr="/home/claude/deck/img/shelf.png"/>
+          <p:cNvPr id="3" name="shelf-life chart" descr="figures/fig4_shelflife.png"/>
           <p:cNvPicPr>
             <a:picLocks noChangeAspect="1"/>
           </p:cNvPicPr>

</xml_diff>